<commit_message>
docs: improve bilingual project walkthrough
</commit_message>
<xml_diff>
--- a/docs/presentations/GUI_TestForge_Test_Team_Training_en_V1.1.pptx
+++ b/docs/presentations/GUI_TestForge_Test_Team_Training_en_V1.1.pptx
@@ -1296,7 +1296,7 @@
               <a:buNone/>
             </a:pPr>
             <a:r>
-              <a:rPr lang="en-US" sz="3200" b="1" dirty="0">
+              <a:rPr lang="en-US" sz="1300" b="1" dirty="0">
                 <a:ln/>
                 <a:gradFill>
                   <a:gsLst>
@@ -1567,7 +1567,7 @@
               <a:buNone/>
             </a:pPr>
             <a:r>
-              <a:rPr lang="en-US" sz="3200" b="1" dirty="0">
+              <a:rPr lang="en-US" sz="1300" b="1" dirty="0">
                 <a:gradFill>
                   <a:gsLst>
                     <a:gs pos="0">
@@ -1596,10 +1596,10 @@
                 <a:latin typeface="PingFang SC Semibold" panose="020B0400000000000000" charset="-122"/>
                 <a:ea typeface="PingFang SC Semibold" panose="020B0400000000000000" charset="-122"/>
               </a:rPr>
-              <a:t>NO AI</a:t>
+              <a:t>NON-AI COMPILER</a:t>
             </a:r>
             <a:r>
-              <a:rPr lang="en-US" altLang="zh-CN" sz="3200" b="1" dirty="0">
+              <a:rPr lang="en-US" altLang="zh-CN" sz="1300" b="1" dirty="0">
                 <a:gradFill>
                   <a:gsLst>
                     <a:gs pos="0">
@@ -1631,7 +1631,7 @@
               <a:t/>
             </a:r>
             <a:r>
-              <a:rPr lang="en-US" sz="3200" b="1" dirty="0">
+              <a:rPr lang="en-US" sz="1300" b="1" dirty="0">
                 <a:gradFill>
                   <a:gsLst>
                     <a:gs pos="0">
@@ -1663,7 +1663,7 @@
               </a:rPr>
               <a:t/>
             </a:r>
-            <a:endParaRPr lang="zh-CN" altLang="en-US" sz="3200" b="1" dirty="0">
+            <a:endParaRPr lang="zh-CN" altLang="en-US" sz="1300" b="1" dirty="0">
               <a:gradFill>
                 <a:gsLst>
                   <a:gs pos="0">

</xml_diff>